<commit_message>
fix(presentation): adjust slide 14 layout placing Thank You at top with details positioned below
</commit_message>
<xml_diff>
--- a/Smart-Horizon-2026-48Hour-Intrnl Hackathon Grand Finale Template (1).pptx
+++ b/Smart-Horizon-2026-48Hour-Intrnl Hackathon Grand Finale Template (1).pptx
@@ -6569,23 +6569,21 @@
         </p:nvSpPr>
         <p:spPr>
           <a:xfrm>
-            <a:off x="381000" y="1885950"/>
-            <a:ext cx="8229600" cy="971550"/>
+            <a:off x="457200" y="457200"/>
+            <a:ext cx="8229600" cy="914400"/>
           </a:xfrm>
         </p:spPr>
         <p:txBody>
           <a:bodyPr/>
           <a:lstStyle/>
           <a:p>
-            <a:r>
-              <a:rPr lang="en-IN" dirty="0" smtClean="0">
-                <a:solidFill>
-                  <a:schemeClr val="accent1">
-                    <a:lumMod val="75000"/>
-                  </a:schemeClr>
-                </a:solidFill>
-                <a:latin typeface="Times New Roman" panose="02020603050405020304" pitchFamily="18" charset="0"/>
-                <a:cs typeface="Times New Roman" panose="02020603050405020304" pitchFamily="18" charset="0"/>
+            <a:pPr algn="ctr"/>
+            <a:r>
+              <a:rPr sz="3600" b="1">
+                <a:solidFill>
+                  <a:srgbClr val="0F172A"/>
+                </a:solidFill>
+                <a:latin typeface="Times New Roman"/>
               </a:rPr>
               <a:t>Thank You</a:t>
             </a:r>
@@ -6682,8 +6680,8 @@
         </p:nvSpPr>
         <p:spPr>
           <a:xfrm>
-            <a:off x="914400" y="2011680"/>
-            <a:ext cx="7315200" cy="2377440"/>
+            <a:off x="457200" y="1508760"/>
+            <a:ext cx="8229600" cy="3017520"/>
           </a:xfrm>
           <a:prstGeom prst="rect">
             <a:avLst/>
@@ -6691,69 +6689,93 @@
           <a:noFill/>
         </p:spPr>
         <p:txBody>
-          <a:bodyPr wrap="none">
+          <a:bodyPr wrap="square">
             <a:spAutoFit/>
           </a:bodyPr>
           <a:lstStyle/>
           <a:p>
-            <a:pPr algn="ctr"/>
-            <a:r>
-              <a:rPr sz="1600" b="1">
+            <a:pPr algn="ctr">
+              <a:spcAft>
+                <a:spcPts val="400"/>
+              </a:spcAft>
+            </a:pPr>
+            <a:r>
+              <a:rPr sz="1550" b="1">
+                <a:solidFill>
+                  <a:srgbClr val="0E7490"/>
+                </a:solidFill>
+                <a:latin typeface="Times New Roman"/>
+              </a:rPr>
+              <a:t>Project SUTRA — Swarm Unified Tactical Reconnaissance Architecture</a:t>
+            </a:r>
+          </a:p>
+          <a:p>
+            <a:pPr algn="ctr">
+              <a:lnSpc>
+                <a:spcPct val="120000"/>
+              </a:lnSpc>
+              <a:spcAft>
+                <a:spcPts val="1000"/>
+              </a:spcAft>
+            </a:pPr>
+            <a:r>
+              <a:rPr sz="1200">
+                <a:solidFill>
+                  <a:srgbClr val="1E293B"/>
+                </a:solidFill>
+                <a:latin typeface="Times New Roman"/>
+              </a:rPr>
+              <a:t>Problem Statement: SH-DST-05  |  Track: Defence &amp; SpaceTech (DST)
+Team ID: SHIH26-TID-361  |  New Horizon College of Engineering (NHCE), Bengaluru</a:t>
+            </a:r>
+          </a:p>
+          <a:p>
+            <a:pPr algn="ctr">
+              <a:spcAft>
+                <a:spcPts val="200"/>
+              </a:spcAft>
+            </a:pPr>
+            <a:r>
+              <a:rPr sz="1200" b="1">
                 <a:solidFill>
                   <a:srgbClr val="0F172A"/>
                 </a:solidFill>
                 <a:latin typeface="Times New Roman"/>
               </a:rPr>
-              <a:t>Project SUTRA — Swarm Unified Tactical Reconnaissance Architecture</a:t>
+              <a:t>Grand Finals Project Team:</a:t>
             </a:r>
           </a:p>
           <a:p>
             <a:pPr algn="ctr">
-              <a:spcBef>
-                <a:spcPts val="800"/>
-              </a:spcBef>
+              <a:spcAft>
+                <a:spcPts val="1400"/>
+              </a:spcAft>
             </a:pPr>
             <a:r>
-              <a:rPr sz="1200">
+              <a:rPr sz="1250" b="1">
                 <a:solidFill>
                   <a:srgbClr val="0E7490"/>
                 </a:solidFill>
                 <a:latin typeface="Times New Roman"/>
               </a:rPr>
-              <a:t>Problem Statement: SH-DST-05 | Track: Defence &amp; SpaceTech (DST)
-Team ID: SHIH26-TID-361 | Host: New Horizon College of Engineering (NHCE)</a:t>
+              <a:t>Nikhil (Team Lead)  •  Vedanth Sai Ram  •  Siva Kesava  •  Harika  •  Rohith Kumar</a:t>
             </a:r>
           </a:p>
           <a:p>
             <a:pPr algn="ctr">
-              <a:spcBef>
-                <a:spcPts val="1200"/>
-              </a:spcBef>
+              <a:spcAft>
+                <a:spcPts val="400"/>
+              </a:spcAft>
             </a:pPr>
             <a:r>
-              <a:rPr sz="1150" b="1">
-                <a:solidFill>
-                  <a:srgbClr val="0F172A"/>
-                </a:solidFill>
-                <a:latin typeface="Times New Roman"/>
-              </a:rPr>
-              <a:t>Team Members: Nikhil (Lead) • Vedanth Sai Ram • Siva Kesava • Harika • Rohith Kumar</a:t>
-            </a:r>
-          </a:p>
-          <a:p>
-            <a:pPr algn="ctr">
-              <a:spcBef>
-                <a:spcPts val="1000"/>
-              </a:spcBef>
-            </a:pPr>
-            <a:r>
-              <a:rPr sz="1100" i="1">
+              <a:rPr sz="1150" i="1">
                 <a:solidFill>
                   <a:srgbClr val="475569"/>
                 </a:solidFill>
                 <a:latin typeface="Times New Roman"/>
               </a:rPr>
-              <a:t>We welcome questions from the jury and invite you to inspect our live digital twin &amp; GCS demonstration!</a:t>
+              <a:t>We welcome questions from the jury and warmly invite you to inspect our
+live Gazebo Sim 8 digital twin, WebGPU GCS &amp; 232-test verification suite.</a:t>
             </a:r>
           </a:p>
         </p:txBody>

</xml_diff>

<commit_message>
style(presentation): increase vertical breathing space between Thank You heading and body content on slide 14
</commit_message>
<xml_diff>
--- a/Smart-Horizon-2026-48Hour-Intrnl Hackathon Grand Finale Template (1).pptx
+++ b/Smart-Horizon-2026-48Hour-Intrnl Hackathon Grand Finale Template (1).pptx
@@ -6569,8 +6569,8 @@
         </p:nvSpPr>
         <p:spPr>
           <a:xfrm>
-            <a:off x="457200" y="457200"/>
-            <a:ext cx="8229600" cy="914400"/>
+            <a:off x="457200" y="365760"/>
+            <a:ext cx="8229600" cy="822960"/>
           </a:xfrm>
         </p:spPr>
         <p:txBody>
@@ -6579,7 +6579,7 @@
           <a:p>
             <a:pPr algn="ctr"/>
             <a:r>
-              <a:rPr sz="3600" b="1">
+              <a:rPr sz="4000" b="1">
                 <a:solidFill>
                   <a:srgbClr val="0F172A"/>
                 </a:solidFill>
@@ -6680,8 +6680,8 @@
         </p:nvSpPr>
         <p:spPr>
           <a:xfrm>
-            <a:off x="457200" y="1508760"/>
-            <a:ext cx="8229600" cy="3017520"/>
+            <a:off x="457200" y="1783080"/>
+            <a:ext cx="8229600" cy="2788920"/>
           </a:xfrm>
           <a:prstGeom prst="rect">
             <a:avLst/>
@@ -6700,7 +6700,7 @@
               </a:spcAft>
             </a:pPr>
             <a:r>
-              <a:rPr sz="1550" b="1">
+              <a:rPr sz="1600" b="1">
                 <a:solidFill>
                   <a:srgbClr val="0E7490"/>
                 </a:solidFill>
@@ -6714,8 +6714,11 @@
               <a:lnSpc>
                 <a:spcPct val="120000"/>
               </a:lnSpc>
+              <a:spcBef>
+                <a:spcPts val="600"/>
+              </a:spcBef>
               <a:spcAft>
-                <a:spcPts val="1000"/>
+                <a:spcPts val="1200"/>
               </a:spcAft>
             </a:pPr>
             <a:r>
@@ -6731,8 +6734,11 @@
           </a:p>
           <a:p>
             <a:pPr algn="ctr">
+              <a:spcBef>
+                <a:spcPts val="600"/>
+              </a:spcBef>
               <a:spcAft>
-                <a:spcPts val="200"/>
+                <a:spcPts val="300"/>
               </a:spcAft>
             </a:pPr>
             <a:r>
@@ -6748,7 +6754,7 @@
           <a:p>
             <a:pPr algn="ctr">
               <a:spcAft>
-                <a:spcPts val="1400"/>
+                <a:spcPts val="1600"/>
               </a:spcAft>
             </a:pPr>
             <a:r>
@@ -6763,6 +6769,9 @@
           </a:p>
           <a:p>
             <a:pPr algn="ctr">
+              <a:spcBef>
+                <a:spcPts val="800"/>
+              </a:spcBef>
               <a:spcAft>
                 <a:spcPts val="400"/>
               </a:spcAft>

</xml_diff>